<commit_message>
Update the final presentation
</commit_message>
<xml_diff>
--- a/presentation/Tailwyndz PPT.pptx
+++ b/presentation/Tailwyndz PPT.pptx
@@ -5,7 +5,7 @@
     <p:sldMasterId id="2147483648" r:id="rId1"/>
   </p:sldMasterIdLst>
   <p:notesMasterIdLst>
-    <p:notesMasterId r:id="rId12"/>
+    <p:notesMasterId r:id="rId13"/>
   </p:notesMasterIdLst>
   <p:sldIdLst>
     <p:sldId id="256" r:id="rId2"/>
@@ -16,30 +16,31 @@
     <p:sldId id="261" r:id="rId7"/>
     <p:sldId id="262" r:id="rId8"/>
     <p:sldId id="263" r:id="rId9"/>
-    <p:sldId id="264" r:id="rId10"/>
-    <p:sldId id="265" r:id="rId11"/>
+    <p:sldId id="266" r:id="rId10"/>
+    <p:sldId id="264" r:id="rId11"/>
+    <p:sldId id="265" r:id="rId12"/>
   </p:sldIdLst>
   <p:sldSz cx="12192000" cy="6858000"/>
   <p:notesSz cx="6858000" cy="12192000"/>
   <p:embeddedFontLst>
     <p:embeddedFont>
-      <p:font typeface="Bitter Medium" panose="020B0604020202020204" charset="0"/>
-      <p:regular r:id="rId13"/>
+      <p:font typeface="Calibri" panose="020F0502020204030204" pitchFamily="34" charset="0"/>
+      <p:regular r:id="rId14"/>
+      <p:bold r:id="rId15"/>
+      <p:italic r:id="rId16"/>
+      <p:boldItalic r:id="rId17"/>
     </p:embeddedFont>
     <p:embeddedFont>
       <p:font typeface="Open Sans" panose="020B0604020202020204" charset="0"/>
-      <p:regular r:id="rId14"/>
-    </p:embeddedFont>
-    <p:embeddedFont>
-      <p:font typeface="Calibri" panose="020F0502020204030204" pitchFamily="34" charset="0"/>
-      <p:regular r:id="rId15"/>
-      <p:bold r:id="rId16"/>
-      <p:italic r:id="rId17"/>
-      <p:boldItalic r:id="rId18"/>
+      <p:regular r:id="rId18"/>
     </p:embeddedFont>
     <p:embeddedFont>
       <p:font typeface="Open Sans Bold" panose="020B0604020202020204" charset="0"/>
       <p:regular r:id="rId19"/>
+    </p:embeddedFont>
+    <p:embeddedFont>
+      <p:font typeface="Bitter Medium" panose="020B0604020202020204" charset="0"/>
+      <p:regular r:id="rId20"/>
     </p:embeddedFont>
   </p:embeddedFontLst>
   <p:defaultTextStyle>
@@ -1164,14 +1165,14 @@
       </p:grpSpPr>
       <p:sp>
         <p:nvSpPr>
-          <p:cNvPr id="56" name="Text 0"/>
-          <p:cNvSpPr/>
-          <p:nvPr/>
-        </p:nvSpPr>
-        <p:spPr>
-          <a:xfrm>
-            <a:off x="661475" y="557709"/>
-            <a:ext cx="10868745" cy="498376"/>
+          <p:cNvPr id="8" name="Text 0"/>
+          <p:cNvSpPr/>
+          <p:nvPr/>
+        </p:nvSpPr>
+        <p:spPr>
+          <a:xfrm>
+            <a:off x="661475" y="1391345"/>
+            <a:ext cx="10868745" cy="590649"/>
           </a:xfrm>
           <a:prstGeom prst="rect">
             <a:avLst/>
@@ -1190,7 +1191,7 @@
               <a:buNone/>
             </a:pPr>
             <a:r>
-              <a:rPr lang="en-US" sz="3100" kern="0" spc="-94" dirty="0">
+              <a:rPr lang="en-US" sz="3700" kern="0" spc="-112" dirty="0">
                 <a:solidFill>
                   <a:srgbClr val="2C3F42"/>
                 </a:solidFill>
@@ -1198,7 +1199,465 @@
                 <a:ea typeface="Bitter Medium" pitchFamily="34" charset="-122"/>
                 <a:cs typeface="Bitter Medium" pitchFamily="34" charset="-120"/>
               </a:rPr>
-              <a:t>Where This Fits in the Command Centre</a:t>
+              <a:t>What the Results Tell Us</a:t>
+            </a:r>
+            <a:endParaRPr lang="en-US" sz="3700" dirty="0"/>
+          </a:p>
+        </p:txBody>
+      </p:sp>
+      <p:sp>
+        <p:nvSpPr>
+          <p:cNvPr id="9" name="Text 1"/>
+          <p:cNvSpPr/>
+          <p:nvPr/>
+        </p:nvSpPr>
+        <p:spPr>
+          <a:xfrm>
+            <a:off x="661475" y="2454473"/>
+            <a:ext cx="5203794" cy="295275"/>
+          </a:xfrm>
+          <a:prstGeom prst="rect">
+            <a:avLst/>
+          </a:prstGeom>
+          <a:noFill/>
+          <a:ln/>
+        </p:spPr>
+        <p:txBody>
+          <a:bodyPr wrap="none" lIns="0" tIns="0" rIns="0" bIns="0" rtlCol="0" anchor="t"/>
+          <a:lstStyle/>
+          <a:p>
+            <a:pPr marL="0" indent="0" algn="l">
+              <a:lnSpc>
+                <a:spcPct val="104000"/>
+              </a:lnSpc>
+              <a:buNone/>
+            </a:pPr>
+            <a:r>
+              <a:rPr lang="en-US" sz="1850" kern="0" spc="-56" dirty="0">
+                <a:solidFill>
+                  <a:srgbClr val="2C3F42"/>
+                </a:solidFill>
+                <a:latin typeface="Bitter Medium" pitchFamily="34" charset="0"/>
+                <a:ea typeface="Bitter Medium" pitchFamily="34" charset="-122"/>
+                <a:cs typeface="Bitter Medium" pitchFamily="34" charset="-120"/>
+              </a:rPr>
+              <a:t>What worked</a:t>
+            </a:r>
+            <a:endParaRPr lang="en-US" sz="1850" dirty="0"/>
+          </a:p>
+        </p:txBody>
+      </p:sp>
+      <p:sp>
+        <p:nvSpPr>
+          <p:cNvPr id="10" name="Text 2"/>
+          <p:cNvSpPr/>
+          <p:nvPr/>
+        </p:nvSpPr>
+        <p:spPr>
+          <a:xfrm>
+            <a:off x="661475" y="2938760"/>
+            <a:ext cx="5203794" cy="1946672"/>
+          </a:xfrm>
+          <a:prstGeom prst="rect">
+            <a:avLst/>
+          </a:prstGeom>
+          <a:noFill/>
+          <a:ln/>
+        </p:spPr>
+        <p:txBody>
+          <a:bodyPr wrap="square" lIns="0" tIns="0" rIns="0" bIns="0" rtlCol="0" anchor="t">
+            <a:normAutofit/>
+          </a:bodyPr>
+          <a:lstStyle/>
+          <a:p>
+            <a:pPr marL="294640" indent="-294640" algn="l">
+              <a:lnSpc>
+                <a:spcPct val="133000"/>
+              </a:lnSpc>
+              <a:buSzPct val="100000"/>
+              <a:buChar char="•"/>
+            </a:pPr>
+            <a:r>
+              <a:rPr lang="en-US" sz="1450" kern="0" spc="-30" dirty="0">
+                <a:solidFill>
+                  <a:srgbClr val="2B2E3C"/>
+                </a:solidFill>
+                <a:latin typeface="Open Sans" pitchFamily="34" charset="0"/>
+                <a:ea typeface="Open Sans" pitchFamily="34" charset="-122"/>
+                <a:cs typeface="Open Sans" pitchFamily="34" charset="-120"/>
+              </a:rPr>
+              <a:t>Automated/irrelevant traffic can be filtered before VSS, reducing noise</a:t>
+            </a:r>
+            <a:endParaRPr lang="en-US" sz="1450" dirty="0"/>
+          </a:p>
+          <a:p>
+            <a:pPr marL="294640" indent="-294640" algn="l">
+              <a:lnSpc>
+                <a:spcPct val="133000"/>
+              </a:lnSpc>
+              <a:buSzPct val="100000"/>
+              <a:buChar char="•"/>
+            </a:pPr>
+            <a:r>
+              <a:rPr lang="en-US" sz="1450" kern="0" spc="-30" dirty="0">
+                <a:solidFill>
+                  <a:srgbClr val="2B2E3C"/>
+                </a:solidFill>
+                <a:latin typeface="Open Sans" pitchFamily="34" charset="0"/>
+                <a:ea typeface="Open Sans" pitchFamily="34" charset="-122"/>
+                <a:cs typeface="Open Sans" pitchFamily="34" charset="-120"/>
+              </a:rPr>
+              <a:t>Isolated sentiment spikes are suppressed by persistence requirement</a:t>
+            </a:r>
+            <a:endParaRPr lang="en-US" sz="1450" dirty="0"/>
+          </a:p>
+          <a:p>
+            <a:pPr marL="294640" indent="-294640" algn="l">
+              <a:lnSpc>
+                <a:spcPct val="133000"/>
+              </a:lnSpc>
+              <a:buSzPct val="100000"/>
+              <a:buChar char="•"/>
+            </a:pPr>
+            <a:r>
+              <a:rPr lang="en-US" sz="1450" kern="0" spc="-30" dirty="0">
+                <a:solidFill>
+                  <a:srgbClr val="2B2E3C"/>
+                </a:solidFill>
+                <a:latin typeface="Open Sans" pitchFamily="34" charset="0"/>
+                <a:ea typeface="Open Sans" pitchFamily="34" charset="-122"/>
+                <a:cs typeface="Open Sans" pitchFamily="34" charset="-120"/>
+              </a:rPr>
+              <a:t>Sustained negative shifts (e.g., sponsor announcement) can be surfaced</a:t>
+            </a:r>
+            <a:endParaRPr lang="en-US" sz="1450" dirty="0"/>
+          </a:p>
+        </p:txBody>
+      </p:sp>
+      <p:sp>
+        <p:nvSpPr>
+          <p:cNvPr id="11" name="Text 3"/>
+          <p:cNvSpPr/>
+          <p:nvPr/>
+        </p:nvSpPr>
+        <p:spPr>
+          <a:xfrm>
+            <a:off x="6332776" y="2454473"/>
+            <a:ext cx="5203794" cy="295275"/>
+          </a:xfrm>
+          <a:prstGeom prst="rect">
+            <a:avLst/>
+          </a:prstGeom>
+          <a:noFill/>
+          <a:ln/>
+        </p:spPr>
+        <p:txBody>
+          <a:bodyPr wrap="none" lIns="0" tIns="0" rIns="0" bIns="0" rtlCol="0" anchor="t"/>
+          <a:lstStyle/>
+          <a:p>
+            <a:pPr marL="0" indent="0" algn="l">
+              <a:lnSpc>
+                <a:spcPct val="104000"/>
+              </a:lnSpc>
+              <a:buNone/>
+            </a:pPr>
+            <a:r>
+              <a:rPr lang="en-US" sz="1850" kern="0" spc="-56" dirty="0">
+                <a:solidFill>
+                  <a:srgbClr val="2C3F42"/>
+                </a:solidFill>
+                <a:latin typeface="Bitter Medium" pitchFamily="34" charset="0"/>
+                <a:ea typeface="Bitter Medium" pitchFamily="34" charset="-122"/>
+                <a:cs typeface="Bitter Medium" pitchFamily="34" charset="-120"/>
+              </a:rPr>
+              <a:t>What didn't work</a:t>
+            </a:r>
+            <a:endParaRPr lang="en-US" sz="1850" dirty="0"/>
+          </a:p>
+        </p:txBody>
+      </p:sp>
+      <p:sp>
+        <p:nvSpPr>
+          <p:cNvPr id="12" name="Text 4"/>
+          <p:cNvSpPr/>
+          <p:nvPr/>
+        </p:nvSpPr>
+        <p:spPr>
+          <a:xfrm>
+            <a:off x="6332776" y="2938760"/>
+            <a:ext cx="5203794" cy="1710333"/>
+          </a:xfrm>
+          <a:prstGeom prst="rect">
+            <a:avLst/>
+          </a:prstGeom>
+          <a:noFill/>
+          <a:ln/>
+        </p:spPr>
+        <p:txBody>
+          <a:bodyPr wrap="square" lIns="0" tIns="0" rIns="0" bIns="0" rtlCol="0" anchor="t">
+            <a:normAutofit/>
+          </a:bodyPr>
+          <a:lstStyle/>
+          <a:p>
+            <a:pPr marL="294640" indent="-294640" algn="l">
+              <a:lnSpc>
+                <a:spcPct val="133000"/>
+              </a:lnSpc>
+              <a:buSzPct val="100000"/>
+              <a:buChar char="•"/>
+            </a:pPr>
+            <a:r>
+              <a:rPr lang="en-US" sz="1450" kern="0" spc="-30" dirty="0">
+                <a:solidFill>
+                  <a:srgbClr val="2B2E3C"/>
+                </a:solidFill>
+                <a:latin typeface="Open Sans" pitchFamily="34" charset="0"/>
+                <a:ea typeface="Open Sans" pitchFamily="34" charset="-122"/>
+                <a:cs typeface="Open Sans" pitchFamily="34" charset="-120"/>
+              </a:rPr>
+              <a:t>Several real incidents were missed — limited coverage</a:t>
+            </a:r>
+            <a:endParaRPr lang="en-US" sz="1450" dirty="0"/>
+          </a:p>
+          <a:p>
+            <a:pPr marL="294640" indent="-294640" algn="l">
+              <a:lnSpc>
+                <a:spcPct val="133000"/>
+              </a:lnSpc>
+              <a:buSzPct val="100000"/>
+              <a:buChar char="•"/>
+            </a:pPr>
+            <a:r>
+              <a:rPr lang="en-US" sz="1450" kern="0" spc="-30" dirty="0">
+                <a:solidFill>
+                  <a:srgbClr val="2B2E3C"/>
+                </a:solidFill>
+                <a:latin typeface="Open Sans" pitchFamily="34" charset="0"/>
+                <a:ea typeface="Open Sans" pitchFamily="34" charset="-122"/>
+                <a:cs typeface="Open Sans" pitchFamily="34" charset="-120"/>
+              </a:rPr>
+              <a:t>Visibility depends on affected people posting</a:t>
+            </a:r>
+            <a:endParaRPr lang="en-US" sz="1450" dirty="0"/>
+          </a:p>
+          <a:p>
+            <a:pPr marL="294640" indent="-294640" algn="l">
+              <a:lnSpc>
+                <a:spcPct val="133000"/>
+              </a:lnSpc>
+              <a:buSzPct val="100000"/>
+              <a:buChar char="•"/>
+            </a:pPr>
+            <a:r>
+              <a:rPr lang="en-US" sz="1450" kern="0" spc="-30" dirty="0">
+                <a:solidFill>
+                  <a:srgbClr val="2B2E3C"/>
+                </a:solidFill>
+                <a:latin typeface="Open Sans" pitchFamily="34" charset="0"/>
+                <a:ea typeface="Open Sans" pitchFamily="34" charset="-122"/>
+                <a:cs typeface="Open Sans" pitchFamily="34" charset="-120"/>
+              </a:rPr>
+              <a:t>Neutral or subtle language can hide operational problems</a:t>
+            </a:r>
+            <a:endParaRPr lang="en-US" sz="1450" dirty="0"/>
+          </a:p>
+          <a:p>
+            <a:pPr marL="294640" indent="-294640" algn="l">
+              <a:lnSpc>
+                <a:spcPct val="133000"/>
+              </a:lnSpc>
+              <a:buSzPct val="100000"/>
+              <a:buChar char="•"/>
+            </a:pPr>
+            <a:r>
+              <a:rPr lang="en-US" sz="1450" kern="0" spc="-30" dirty="0">
+                <a:solidFill>
+                  <a:srgbClr val="2B2E3C"/>
+                </a:solidFill>
+                <a:latin typeface="Open Sans" pitchFamily="34" charset="0"/>
+                <a:ea typeface="Open Sans" pitchFamily="34" charset="-122"/>
+                <a:cs typeface="Open Sans" pitchFamily="34" charset="-120"/>
+              </a:rPr>
+              <a:t>Missing geography (30.12%) reduces market-level sensitivity</a:t>
+            </a:r>
+            <a:endParaRPr lang="en-US" sz="1450" dirty="0"/>
+          </a:p>
+        </p:txBody>
+      </p:sp>
+      <p:sp>
+        <p:nvSpPr>
+          <p:cNvPr id="13" name="Text 5"/>
+          <p:cNvSpPr/>
+          <p:nvPr/>
+        </p:nvSpPr>
+        <p:spPr>
+          <a:xfrm>
+            <a:off x="661475" y="5164138"/>
+            <a:ext cx="11478330" cy="302419"/>
+          </a:xfrm>
+          <a:prstGeom prst="rect">
+            <a:avLst/>
+          </a:prstGeom>
+          <a:noFill/>
+          <a:ln/>
+        </p:spPr>
+        <p:txBody>
+          <a:bodyPr wrap="none" lIns="0" tIns="0" rIns="0" bIns="0" rtlCol="0" anchor="t"/>
+          <a:lstStyle/>
+          <a:p>
+            <a:pPr marL="0" indent="0" algn="l">
+              <a:lnSpc>
+                <a:spcPct val="133000"/>
+              </a:lnSpc>
+              <a:buNone/>
+            </a:pPr>
+            <a:r>
+              <a:rPr lang="en-US" sz="1450" b="1" kern="0" spc="-30" dirty="0">
+                <a:solidFill>
+                  <a:srgbClr val="2B2E3C"/>
+                </a:solidFill>
+                <a:latin typeface="Open Sans Bold" pitchFamily="34" charset="0"/>
+                <a:ea typeface="Open Sans Bold" pitchFamily="34" charset="-122"/>
+                <a:cs typeface="Open Sans Bold" pitchFamily="34" charset="-120"/>
+              </a:rPr>
+              <a:t>Conclusion:</a:t>
+            </a:r>
+            <a:r>
+              <a:rPr lang="en-US" sz="1450" kern="0" spc="-30" dirty="0">
+                <a:solidFill>
+                  <a:srgbClr val="2B2E3C"/>
+                </a:solidFill>
+                <a:latin typeface="Open Sans" pitchFamily="34" charset="0"/>
+                <a:ea typeface="Open Sans" pitchFamily="34" charset="-122"/>
+                <a:cs typeface="Open Sans" pitchFamily="34" charset="-120"/>
+              </a:rPr>
+              <a:t> Useful as an early-warning layer, not sufficient as a standalone incident detector.</a:t>
+            </a:r>
+            <a:endParaRPr lang="en-US" sz="1450" dirty="0"/>
+          </a:p>
+        </p:txBody>
+      </p:sp>
+      <p:sp>
+        <p:nvSpPr>
+          <p:cNvPr id="14" name="Rectangle 13"/>
+          <p:cNvSpPr/>
+          <p:nvPr/>
+        </p:nvSpPr>
+        <p:spPr>
+          <a:xfrm>
+            <a:off x="11034346" y="6506308"/>
+            <a:ext cx="1069960" cy="290146"/>
+          </a:xfrm>
+          <a:prstGeom prst="rect">
+            <a:avLst/>
+          </a:prstGeom>
+          <a:solidFill>
+            <a:srgbClr val="FFF8F0"/>
+          </a:solidFill>
+          <a:ln>
+            <a:solidFill>
+              <a:srgbClr val="FFF8F0"/>
+            </a:solidFill>
+          </a:ln>
+        </p:spPr>
+        <p:style>
+          <a:lnRef idx="2">
+            <a:schemeClr val="accent1">
+              <a:shade val="50000"/>
+            </a:schemeClr>
+          </a:lnRef>
+          <a:fillRef idx="1">
+            <a:schemeClr val="accent1"/>
+          </a:fillRef>
+          <a:effectRef idx="0">
+            <a:schemeClr val="accent1"/>
+          </a:effectRef>
+          <a:fontRef idx="minor">
+            <a:schemeClr val="lt1"/>
+          </a:fontRef>
+        </p:style>
+        <p:txBody>
+          <a:bodyPr rtlCol="0" anchor="ctr"/>
+          <a:lstStyle/>
+          <a:p>
+            <a:pPr algn="ctr"/>
+            <a:endParaRPr lang="en-IN"/>
+          </a:p>
+        </p:txBody>
+      </p:sp>
+    </p:spTree>
+    <p:extLst>
+      <p:ext uri="{BB962C8B-B14F-4D97-AF65-F5344CB8AC3E}">
+        <p14:creationId xmlns:p14="http://schemas.microsoft.com/office/powerpoint/2010/main" val="3042063563"/>
+      </p:ext>
+    </p:extLst>
+  </p:cSld>
+  <p:clrMapOvr>
+    <a:masterClrMapping/>
+  </p:clrMapOvr>
+  <p:timing>
+    <p:tnLst>
+      <p:par>
+        <p:cTn id="1" dur="indefinite" restart="never" nodeType="tmRoot"/>
+      </p:par>
+    </p:tnLst>
+  </p:timing>
+</p:sld>
+</file>
+
+<file path=ppt/slides/slide11.xml><?xml version="1.0" encoding="utf-8"?>
+<p:sld xmlns:a="http://schemas.openxmlformats.org/drawingml/2006/main" xmlns:r="http://schemas.openxmlformats.org/officeDocument/2006/relationships" xmlns:p="http://schemas.openxmlformats.org/presentationml/2006/main">
+  <p:cSld>
+    <p:spTree>
+      <p:nvGrpSpPr>
+        <p:cNvPr id="1" name=""/>
+        <p:cNvGrpSpPr/>
+        <p:nvPr/>
+      </p:nvGrpSpPr>
+      <p:grpSpPr>
+        <a:xfrm>
+          <a:off x="0" y="0"/>
+          <a:ext cx="0" cy="0"/>
+          <a:chOff x="0" y="0"/>
+          <a:chExt cx="0" cy="0"/>
+        </a:xfrm>
+      </p:grpSpPr>
+      <p:sp>
+        <p:nvSpPr>
+          <p:cNvPr id="56" name="Text 0"/>
+          <p:cNvSpPr/>
+          <p:nvPr/>
+        </p:nvSpPr>
+        <p:spPr>
+          <a:xfrm>
+            <a:off x="661475" y="557709"/>
+            <a:ext cx="10868745" cy="498376"/>
+          </a:xfrm>
+          <a:prstGeom prst="rect">
+            <a:avLst/>
+          </a:prstGeom>
+          <a:noFill/>
+          <a:ln/>
+        </p:spPr>
+        <p:txBody>
+          <a:bodyPr wrap="none" lIns="0" tIns="0" rIns="0" bIns="0" rtlCol="0" anchor="t"/>
+          <a:lstStyle/>
+          <a:p>
+            <a:pPr>
+              <a:lnSpc>
+                <a:spcPct val="104000"/>
+              </a:lnSpc>
+            </a:pPr>
+            <a:r>
+              <a:rPr lang="en-US" sz="3100" kern="0" spc="-94" dirty="0">
+                <a:solidFill>
+                  <a:srgbClr val="2C3F42"/>
+                </a:solidFill>
+                <a:latin typeface="Bitter Medium" pitchFamily="34" charset="0"/>
+                <a:ea typeface="Bitter Medium" pitchFamily="34" charset="-122"/>
+                <a:cs typeface="Bitter Medium" pitchFamily="34" charset="-120"/>
+              </a:rPr>
+              <a:t>How the Command Centre Would Use the Signal</a:t>
             </a:r>
             <a:endParaRPr lang="en-US" sz="3100" dirty="0"/>
           </a:p>
@@ -2156,6 +2615,54 @@
               <a:t>System CANNOT reliably see incidents where affected people are not posting, neutral-language operational reports, or posts lacking market data.</a:t>
             </a:r>
             <a:endParaRPr lang="en-US" sz="1250" dirty="0"/>
+          </a:p>
+        </p:txBody>
+      </p:sp>
+      <p:sp>
+        <p:nvSpPr>
+          <p:cNvPr id="29" name="Rectangle 28"/>
+          <p:cNvSpPr/>
+          <p:nvPr/>
+        </p:nvSpPr>
+        <p:spPr>
+          <a:xfrm>
+            <a:off x="11034346" y="6506308"/>
+            <a:ext cx="1069960" cy="290146"/>
+          </a:xfrm>
+          <a:prstGeom prst="rect">
+            <a:avLst/>
+          </a:prstGeom>
+          <a:solidFill>
+            <a:srgbClr val="FFF8F0"/>
+          </a:solidFill>
+          <a:ln>
+            <a:solidFill>
+              <a:srgbClr val="FFF8F0"/>
+            </a:solidFill>
+          </a:ln>
+        </p:spPr>
+        <p:style>
+          <a:lnRef idx="2">
+            <a:schemeClr val="accent1">
+              <a:shade val="50000"/>
+            </a:schemeClr>
+          </a:lnRef>
+          <a:fillRef idx="1">
+            <a:schemeClr val="accent1"/>
+          </a:fillRef>
+          <a:effectRef idx="0">
+            <a:schemeClr val="accent1"/>
+          </a:effectRef>
+          <a:fontRef idx="minor">
+            <a:schemeClr val="lt1"/>
+          </a:fontRef>
+        </p:style>
+        <p:txBody>
+          <a:bodyPr rtlCol="0" anchor="ctr"/>
+          <a:lstStyle/>
+          <a:p>
+            <a:pPr algn="ctr"/>
+            <a:endParaRPr lang="en-IN"/>
           </a:p>
         </p:txBody>
       </p:sp>
@@ -3256,6 +3763,54 @@
               <a:t> Python analysis pipeline + structured outputs. Production extension: command-centre dashboard / alerting interface (not built here).</a:t>
             </a:r>
             <a:endParaRPr lang="en-US" sz="1450" dirty="0"/>
+          </a:p>
+        </p:txBody>
+      </p:sp>
+      <p:sp>
+        <p:nvSpPr>
+          <p:cNvPr id="31" name="Rectangle 30"/>
+          <p:cNvSpPr/>
+          <p:nvPr/>
+        </p:nvSpPr>
+        <p:spPr>
+          <a:xfrm>
+            <a:off x="11034346" y="6506308"/>
+            <a:ext cx="1069960" cy="290146"/>
+          </a:xfrm>
+          <a:prstGeom prst="rect">
+            <a:avLst/>
+          </a:prstGeom>
+          <a:solidFill>
+            <a:srgbClr val="FFF8F0"/>
+          </a:solidFill>
+          <a:ln>
+            <a:solidFill>
+              <a:srgbClr val="FFF8F0"/>
+            </a:solidFill>
+          </a:ln>
+        </p:spPr>
+        <p:style>
+          <a:lnRef idx="2">
+            <a:schemeClr val="accent1">
+              <a:shade val="50000"/>
+            </a:schemeClr>
+          </a:lnRef>
+          <a:fillRef idx="1">
+            <a:schemeClr val="accent1"/>
+          </a:fillRef>
+          <a:effectRef idx="0">
+            <a:schemeClr val="accent1"/>
+          </a:effectRef>
+          <a:fontRef idx="minor">
+            <a:schemeClr val="lt1"/>
+          </a:fontRef>
+        </p:style>
+        <p:txBody>
+          <a:bodyPr rtlCol="0" anchor="ctr"/>
+          <a:lstStyle/>
+          <a:p>
+            <a:pPr algn="ctr"/>
+            <a:endParaRPr lang="en-IN"/>
           </a:p>
         </p:txBody>
       </p:sp>
@@ -4833,6 +5388,54 @@
           </a:p>
         </p:txBody>
       </p:sp>
+      <p:sp>
+        <p:nvSpPr>
+          <p:cNvPr id="8" name="Rectangle 7"/>
+          <p:cNvSpPr/>
+          <p:nvPr/>
+        </p:nvSpPr>
+        <p:spPr>
+          <a:xfrm>
+            <a:off x="11034346" y="6515100"/>
+            <a:ext cx="1069960" cy="290146"/>
+          </a:xfrm>
+          <a:prstGeom prst="rect">
+            <a:avLst/>
+          </a:prstGeom>
+          <a:solidFill>
+            <a:srgbClr val="FFF8F0"/>
+          </a:solidFill>
+          <a:ln>
+            <a:solidFill>
+              <a:srgbClr val="FFF8F0"/>
+            </a:solidFill>
+          </a:ln>
+        </p:spPr>
+        <p:style>
+          <a:lnRef idx="2">
+            <a:schemeClr val="accent1">
+              <a:shade val="50000"/>
+            </a:schemeClr>
+          </a:lnRef>
+          <a:fillRef idx="1">
+            <a:schemeClr val="accent1"/>
+          </a:fillRef>
+          <a:effectRef idx="0">
+            <a:schemeClr val="accent1"/>
+          </a:effectRef>
+          <a:fontRef idx="minor">
+            <a:schemeClr val="lt1"/>
+          </a:fontRef>
+        </p:style>
+        <p:txBody>
+          <a:bodyPr rtlCol="0" anchor="ctr"/>
+          <a:lstStyle/>
+          <a:p>
+            <a:pPr algn="ctr"/>
+            <a:endParaRPr lang="en-IN"/>
+          </a:p>
+        </p:txBody>
+      </p:sp>
     </p:spTree>
     <p:extLst>
       <p:ext uri="{BB962C8B-B14F-4D97-AF65-F5344CB8AC3E}">
@@ -6104,6 +6707,54 @@
           </a:p>
         </p:txBody>
       </p:sp>
+      <p:sp>
+        <p:nvSpPr>
+          <p:cNvPr id="33" name="Rectangle 32"/>
+          <p:cNvSpPr/>
+          <p:nvPr/>
+        </p:nvSpPr>
+        <p:spPr>
+          <a:xfrm>
+            <a:off x="11034346" y="6506308"/>
+            <a:ext cx="1069960" cy="290146"/>
+          </a:xfrm>
+          <a:prstGeom prst="rect">
+            <a:avLst/>
+          </a:prstGeom>
+          <a:solidFill>
+            <a:srgbClr val="FFF8F0"/>
+          </a:solidFill>
+          <a:ln>
+            <a:solidFill>
+              <a:srgbClr val="FFF8F0"/>
+            </a:solidFill>
+          </a:ln>
+        </p:spPr>
+        <p:style>
+          <a:lnRef idx="2">
+            <a:schemeClr val="accent1">
+              <a:shade val="50000"/>
+            </a:schemeClr>
+          </a:lnRef>
+          <a:fillRef idx="1">
+            <a:schemeClr val="accent1"/>
+          </a:fillRef>
+          <a:effectRef idx="0">
+            <a:schemeClr val="accent1"/>
+          </a:effectRef>
+          <a:fontRef idx="minor">
+            <a:schemeClr val="lt1"/>
+          </a:fontRef>
+        </p:style>
+        <p:txBody>
+          <a:bodyPr rtlCol="0" anchor="ctr"/>
+          <a:lstStyle/>
+          <a:p>
+            <a:pPr algn="ctr"/>
+            <a:endParaRPr lang="en-IN"/>
+          </a:p>
+        </p:txBody>
+      </p:sp>
     </p:spTree>
     <p:extLst>
       <p:ext uri="{BB962C8B-B14F-4D97-AF65-F5344CB8AC3E}">
@@ -6712,6 +7363,54 @@
           </a:p>
         </p:txBody>
       </p:sp>
+      <p:sp>
+        <p:nvSpPr>
+          <p:cNvPr id="14" name="Rectangle 13"/>
+          <p:cNvSpPr/>
+          <p:nvPr/>
+        </p:nvSpPr>
+        <p:spPr>
+          <a:xfrm>
+            <a:off x="11034346" y="6506308"/>
+            <a:ext cx="1069960" cy="290146"/>
+          </a:xfrm>
+          <a:prstGeom prst="rect">
+            <a:avLst/>
+          </a:prstGeom>
+          <a:solidFill>
+            <a:srgbClr val="FFF8F0"/>
+          </a:solidFill>
+          <a:ln>
+            <a:solidFill>
+              <a:srgbClr val="FFF8F0"/>
+            </a:solidFill>
+          </a:ln>
+        </p:spPr>
+        <p:style>
+          <a:lnRef idx="2">
+            <a:schemeClr val="accent1">
+              <a:shade val="50000"/>
+            </a:schemeClr>
+          </a:lnRef>
+          <a:fillRef idx="1">
+            <a:schemeClr val="accent1"/>
+          </a:fillRef>
+          <a:effectRef idx="0">
+            <a:schemeClr val="accent1"/>
+          </a:effectRef>
+          <a:fontRef idx="minor">
+            <a:schemeClr val="lt1"/>
+          </a:fontRef>
+        </p:style>
+        <p:txBody>
+          <a:bodyPr rtlCol="0" anchor="ctr"/>
+          <a:lstStyle/>
+          <a:p>
+            <a:pPr algn="ctr"/>
+            <a:endParaRPr lang="en-IN"/>
+          </a:p>
+        </p:txBody>
+      </p:sp>
     </p:spTree>
     <p:extLst>
       <p:ext uri="{BB962C8B-B14F-4D97-AF65-F5344CB8AC3E}">
@@ -7266,6 +7965,54 @@
           </a:p>
         </p:txBody>
       </p:sp>
+      <p:sp>
+        <p:nvSpPr>
+          <p:cNvPr id="11" name="Rectangle 10"/>
+          <p:cNvSpPr/>
+          <p:nvPr/>
+        </p:nvSpPr>
+        <p:spPr>
+          <a:xfrm>
+            <a:off x="11034346" y="6506308"/>
+            <a:ext cx="1069960" cy="290146"/>
+          </a:xfrm>
+          <a:prstGeom prst="rect">
+            <a:avLst/>
+          </a:prstGeom>
+          <a:solidFill>
+            <a:srgbClr val="FFF8F0"/>
+          </a:solidFill>
+          <a:ln>
+            <a:solidFill>
+              <a:srgbClr val="FFF8F0"/>
+            </a:solidFill>
+          </a:ln>
+        </p:spPr>
+        <p:style>
+          <a:lnRef idx="2">
+            <a:schemeClr val="accent1">
+              <a:shade val="50000"/>
+            </a:schemeClr>
+          </a:lnRef>
+          <a:fillRef idx="1">
+            <a:schemeClr val="accent1"/>
+          </a:fillRef>
+          <a:effectRef idx="0">
+            <a:schemeClr val="accent1"/>
+          </a:effectRef>
+          <a:fontRef idx="minor">
+            <a:schemeClr val="lt1"/>
+          </a:fontRef>
+        </p:style>
+        <p:txBody>
+          <a:bodyPr rtlCol="0" anchor="ctr"/>
+          <a:lstStyle/>
+          <a:p>
+            <a:pPr algn="ctr"/>
+            <a:endParaRPr lang="en-IN"/>
+          </a:p>
+        </p:txBody>
+      </p:sp>
     </p:spTree>
     <p:extLst>
       <p:ext uri="{BB962C8B-B14F-4D97-AF65-F5344CB8AC3E}">
@@ -7863,6 +8610,54 @@
               <a:t>Persistence suppresses isolated spikes; sustained breaches reach escalation.</a:t>
             </a:r>
             <a:endParaRPr lang="en-US" sz="1450" dirty="0"/>
+          </a:p>
+        </p:txBody>
+      </p:sp>
+      <p:sp>
+        <p:nvSpPr>
+          <p:cNvPr id="17" name="Rectangle 16"/>
+          <p:cNvSpPr/>
+          <p:nvPr/>
+        </p:nvSpPr>
+        <p:spPr>
+          <a:xfrm>
+            <a:off x="11034346" y="6506308"/>
+            <a:ext cx="1069960" cy="290146"/>
+          </a:xfrm>
+          <a:prstGeom prst="rect">
+            <a:avLst/>
+          </a:prstGeom>
+          <a:solidFill>
+            <a:srgbClr val="FFF8F0"/>
+          </a:solidFill>
+          <a:ln>
+            <a:solidFill>
+              <a:srgbClr val="FFF8F0"/>
+            </a:solidFill>
+          </a:ln>
+        </p:spPr>
+        <p:style>
+          <a:lnRef idx="2">
+            <a:schemeClr val="accent1">
+              <a:shade val="50000"/>
+            </a:schemeClr>
+          </a:lnRef>
+          <a:fillRef idx="1">
+            <a:schemeClr val="accent1"/>
+          </a:fillRef>
+          <a:effectRef idx="0">
+            <a:schemeClr val="accent1"/>
+          </a:effectRef>
+          <a:fontRef idx="minor">
+            <a:schemeClr val="lt1"/>
+          </a:fontRef>
+        </p:style>
+        <p:txBody>
+          <a:bodyPr rtlCol="0" anchor="ctr"/>
+          <a:lstStyle/>
+          <a:p>
+            <a:pPr algn="ctr"/>
+            <a:endParaRPr lang="en-IN"/>
           </a:p>
         </p:txBody>
       </p:sp>
@@ -8776,6 +9571,54 @@
           </a:p>
         </p:txBody>
       </p:sp>
+      <p:sp>
+        <p:nvSpPr>
+          <p:cNvPr id="16" name="Rectangle 15"/>
+          <p:cNvSpPr/>
+          <p:nvPr/>
+        </p:nvSpPr>
+        <p:spPr>
+          <a:xfrm>
+            <a:off x="11034346" y="6506308"/>
+            <a:ext cx="1069960" cy="290146"/>
+          </a:xfrm>
+          <a:prstGeom prst="rect">
+            <a:avLst/>
+          </a:prstGeom>
+          <a:solidFill>
+            <a:srgbClr val="FFF8F0"/>
+          </a:solidFill>
+          <a:ln>
+            <a:solidFill>
+              <a:srgbClr val="FFF8F0"/>
+            </a:solidFill>
+          </a:ln>
+        </p:spPr>
+        <p:style>
+          <a:lnRef idx="2">
+            <a:schemeClr val="accent1">
+              <a:shade val="50000"/>
+            </a:schemeClr>
+          </a:lnRef>
+          <a:fillRef idx="1">
+            <a:schemeClr val="accent1"/>
+          </a:fillRef>
+          <a:effectRef idx="0">
+            <a:schemeClr val="accent1"/>
+          </a:effectRef>
+          <a:fontRef idx="minor">
+            <a:schemeClr val="lt1"/>
+          </a:fontRef>
+        </p:style>
+        <p:txBody>
+          <a:bodyPr rtlCol="0" anchor="ctr"/>
+          <a:lstStyle/>
+          <a:p>
+            <a:pPr algn="ctr"/>
+            <a:endParaRPr lang="en-IN"/>
+          </a:p>
+        </p:txBody>
+      </p:sp>
     </p:spTree>
     <p:extLst>
       <p:ext uri="{BB962C8B-B14F-4D97-AF65-F5344CB8AC3E}">
@@ -8815,395 +9658,216 @@
       </p:grpSpPr>
       <p:sp>
         <p:nvSpPr>
-          <p:cNvPr id="8" name="Text 0"/>
-          <p:cNvSpPr/>
-          <p:nvPr/>
-        </p:nvSpPr>
-        <p:spPr>
-          <a:xfrm>
-            <a:off x="661475" y="1391345"/>
-            <a:ext cx="10868745" cy="590649"/>
-          </a:xfrm>
-          <a:prstGeom prst="rect">
-            <a:avLst/>
-          </a:prstGeom>
-          <a:noFill/>
-          <a:ln/>
-        </p:spPr>
-        <p:txBody>
-          <a:bodyPr wrap="none" lIns="0" tIns="0" rIns="0" bIns="0" rtlCol="0" anchor="t"/>
-          <a:lstStyle/>
-          <a:p>
-            <a:pPr marL="0" indent="0" algn="l">
-              <a:lnSpc>
-                <a:spcPct val="104000"/>
-              </a:lnSpc>
-              <a:buNone/>
-            </a:pPr>
-            <a:r>
-              <a:rPr lang="en-US" sz="3700" kern="0" spc="-112" dirty="0">
-                <a:solidFill>
-                  <a:srgbClr val="2C3F42"/>
-                </a:solidFill>
-                <a:latin typeface="Bitter Medium" pitchFamily="34" charset="0"/>
-                <a:ea typeface="Bitter Medium" pitchFamily="34" charset="-122"/>
-                <a:cs typeface="Bitter Medium" pitchFamily="34" charset="-120"/>
-              </a:rPr>
-              <a:t>What the Results Tell Us</a:t>
-            </a:r>
-            <a:endParaRPr lang="en-US" sz="3700" dirty="0"/>
-          </a:p>
-        </p:txBody>
-      </p:sp>
-      <p:sp>
-        <p:nvSpPr>
-          <p:cNvPr id="9" name="Text 1"/>
-          <p:cNvSpPr/>
-          <p:nvPr/>
-        </p:nvSpPr>
-        <p:spPr>
-          <a:xfrm>
-            <a:off x="661475" y="2454473"/>
-            <a:ext cx="5203794" cy="295275"/>
-          </a:xfrm>
-          <a:prstGeom prst="rect">
-            <a:avLst/>
-          </a:prstGeom>
-          <a:noFill/>
-          <a:ln/>
-        </p:spPr>
-        <p:txBody>
-          <a:bodyPr wrap="none" lIns="0" tIns="0" rIns="0" bIns="0" rtlCol="0" anchor="t"/>
-          <a:lstStyle/>
-          <a:p>
-            <a:pPr marL="0" indent="0" algn="l">
-              <a:lnSpc>
-                <a:spcPct val="104000"/>
-              </a:lnSpc>
-              <a:buNone/>
-            </a:pPr>
-            <a:r>
-              <a:rPr lang="en-US" sz="1850" kern="0" spc="-56" dirty="0">
-                <a:solidFill>
-                  <a:srgbClr val="2C3F42"/>
-                </a:solidFill>
-                <a:latin typeface="Bitter Medium" pitchFamily="34" charset="0"/>
-                <a:ea typeface="Bitter Medium" pitchFamily="34" charset="-122"/>
-                <a:cs typeface="Bitter Medium" pitchFamily="34" charset="-120"/>
-              </a:rPr>
-              <a:t>What worked</a:t>
-            </a:r>
-            <a:endParaRPr lang="en-US" sz="1850" dirty="0"/>
-          </a:p>
-        </p:txBody>
-      </p:sp>
-      <p:sp>
-        <p:nvSpPr>
-          <p:cNvPr id="10" name="Text 2"/>
-          <p:cNvSpPr/>
-          <p:nvPr/>
-        </p:nvSpPr>
-        <p:spPr>
-          <a:xfrm>
-            <a:off x="661475" y="2938760"/>
-            <a:ext cx="5203794" cy="1946672"/>
-          </a:xfrm>
-          <a:prstGeom prst="rect">
-            <a:avLst/>
-          </a:prstGeom>
-          <a:noFill/>
-          <a:ln/>
-        </p:spPr>
-        <p:txBody>
-          <a:bodyPr wrap="square" lIns="0" tIns="0" rIns="0" bIns="0" rtlCol="0" anchor="t">
-            <a:normAutofit/>
+          <p:cNvPr id="2" name="Rectangle 1"/>
+          <p:cNvSpPr/>
+          <p:nvPr/>
+        </p:nvSpPr>
+        <p:spPr>
+          <a:xfrm>
+            <a:off x="11034346" y="6506308"/>
+            <a:ext cx="1069960" cy="290146"/>
+          </a:xfrm>
+          <a:prstGeom prst="rect">
+            <a:avLst/>
+          </a:prstGeom>
+          <a:solidFill>
+            <a:srgbClr val="FFF8F0"/>
+          </a:solidFill>
+          <a:ln>
+            <a:solidFill>
+              <a:srgbClr val="FFF8F0"/>
+            </a:solidFill>
+          </a:ln>
+        </p:spPr>
+        <p:style>
+          <a:lnRef idx="2">
+            <a:schemeClr val="accent1">
+              <a:shade val="50000"/>
+            </a:schemeClr>
+          </a:lnRef>
+          <a:fillRef idx="1">
+            <a:schemeClr val="accent1"/>
+          </a:fillRef>
+          <a:effectRef idx="0">
+            <a:schemeClr val="accent1"/>
+          </a:effectRef>
+          <a:fontRef idx="minor">
+            <a:schemeClr val="lt1"/>
+          </a:fontRef>
+        </p:style>
+        <p:txBody>
+          <a:bodyPr rtlCol="0" anchor="ctr"/>
+          <a:lstStyle/>
+          <a:p>
+            <a:pPr algn="ctr"/>
+            <a:endParaRPr lang="en-IN"/>
+          </a:p>
+        </p:txBody>
+      </p:sp>
+      <p:pic>
+        <p:nvPicPr>
+          <p:cNvPr id="3" name="Picture 2"/>
+          <p:cNvPicPr>
+            <a:picLocks noChangeAspect="1"/>
+          </p:cNvPicPr>
+          <p:nvPr/>
+        </p:nvPicPr>
+        <p:blipFill>
+          <a:blip r:embed="rId2"/>
+          <a:stretch>
+            <a:fillRect/>
+          </a:stretch>
+        </p:blipFill>
+        <p:spPr>
+          <a:xfrm>
+            <a:off x="1380744" y="1317125"/>
+            <a:ext cx="9059242" cy="4111202"/>
+          </a:xfrm>
+          <a:prstGeom prst="rect">
+            <a:avLst/>
+          </a:prstGeom>
+        </p:spPr>
+      </p:pic>
+      <p:sp>
+        <p:nvSpPr>
+          <p:cNvPr id="4" name="Rectangle 3"/>
+          <p:cNvSpPr/>
+          <p:nvPr/>
+        </p:nvSpPr>
+        <p:spPr>
+          <a:xfrm>
+            <a:off x="483870" y="455414"/>
+            <a:ext cx="10225876" cy="623248"/>
+          </a:xfrm>
+          <a:prstGeom prst="rect">
+            <a:avLst/>
+          </a:prstGeom>
+        </p:spPr>
+        <p:txBody>
+          <a:bodyPr wrap="none">
+            <a:spAutoFit/>
           </a:bodyPr>
           <a:lstStyle/>
           <a:p>
-            <a:pPr marL="294640" indent="-294640" algn="l">
-              <a:lnSpc>
-                <a:spcPct val="133000"/>
-              </a:lnSpc>
-              <a:buSzPct val="100000"/>
-              <a:buChar char="•"/>
-            </a:pPr>
-            <a:r>
-              <a:rPr lang="en-US" sz="1450" kern="0" spc="-30" dirty="0">
-                <a:solidFill>
-                  <a:srgbClr val="2B2E3C"/>
-                </a:solidFill>
-                <a:latin typeface="Open Sans" pitchFamily="34" charset="0"/>
-                <a:ea typeface="Open Sans" pitchFamily="34" charset="-122"/>
-                <a:cs typeface="Open Sans" pitchFamily="34" charset="-120"/>
-              </a:rPr>
-              <a:t>Automated/irrelevant traffic can be filtered before VSS, reducing noise</a:t>
-            </a:r>
-            <a:endParaRPr lang="en-US" sz="1450" dirty="0"/>
-          </a:p>
-          <a:p>
-            <a:pPr marL="294640" indent="-294640" algn="l">
-              <a:lnSpc>
-                <a:spcPct val="133000"/>
-              </a:lnSpc>
-              <a:buSzPct val="100000"/>
-              <a:buChar char="•"/>
-            </a:pPr>
-            <a:r>
-              <a:rPr lang="en-US" sz="1450" kern="0" spc="-30" dirty="0">
-                <a:solidFill>
-                  <a:srgbClr val="2B2E3C"/>
-                </a:solidFill>
-                <a:latin typeface="Open Sans" pitchFamily="34" charset="0"/>
-                <a:ea typeface="Open Sans" pitchFamily="34" charset="-122"/>
-                <a:cs typeface="Open Sans" pitchFamily="34" charset="-120"/>
-              </a:rPr>
-              <a:t>Isolated sentiment spikes are suppressed by persistence requirement</a:t>
-            </a:r>
-            <a:endParaRPr lang="en-US" sz="1450" dirty="0"/>
-          </a:p>
-          <a:p>
-            <a:pPr marL="294640" indent="-294640" algn="l">
-              <a:lnSpc>
-                <a:spcPct val="133000"/>
-              </a:lnSpc>
-              <a:buSzPct val="100000"/>
-              <a:buChar char="•"/>
-            </a:pPr>
-            <a:r>
-              <a:rPr lang="en-US" sz="1450" kern="0" spc="-30" dirty="0">
-                <a:solidFill>
-                  <a:srgbClr val="2B2E3C"/>
-                </a:solidFill>
-                <a:latin typeface="Open Sans" pitchFamily="34" charset="0"/>
-                <a:ea typeface="Open Sans" pitchFamily="34" charset="-122"/>
-                <a:cs typeface="Open Sans" pitchFamily="34" charset="-120"/>
-              </a:rPr>
-              <a:t>Sustained negative shifts (e.g., sponsor announcement) can be surfaced</a:t>
-            </a:r>
-            <a:endParaRPr lang="en-US" sz="1450" dirty="0"/>
-          </a:p>
-        </p:txBody>
-      </p:sp>
-      <p:sp>
-        <p:nvSpPr>
-          <p:cNvPr id="11" name="Text 3"/>
-          <p:cNvSpPr/>
-          <p:nvPr/>
-        </p:nvSpPr>
-        <p:spPr>
-          <a:xfrm>
-            <a:off x="6332776" y="2454473"/>
-            <a:ext cx="5203794" cy="295275"/>
-          </a:xfrm>
-          <a:prstGeom prst="rect">
-            <a:avLst/>
-          </a:prstGeom>
-          <a:noFill/>
-          <a:ln/>
-        </p:spPr>
-        <p:txBody>
-          <a:bodyPr wrap="none" lIns="0" tIns="0" rIns="0" bIns="0" rtlCol="0" anchor="t"/>
-          <a:lstStyle/>
-          <a:p>
-            <a:pPr marL="0" indent="0" algn="l">
-              <a:lnSpc>
-                <a:spcPct val="104000"/>
-              </a:lnSpc>
-              <a:buNone/>
-            </a:pPr>
-            <a:r>
-              <a:rPr lang="en-US" sz="1850" kern="0" spc="-56" dirty="0">
-                <a:solidFill>
-                  <a:srgbClr val="2C3F42"/>
-                </a:solidFill>
-                <a:latin typeface="Bitter Medium" pitchFamily="34" charset="0"/>
-                <a:ea typeface="Bitter Medium" pitchFamily="34" charset="-122"/>
-                <a:cs typeface="Bitter Medium" pitchFamily="34" charset="-120"/>
-              </a:rPr>
-              <a:t>What didn't work</a:t>
-            </a:r>
-            <a:endParaRPr lang="en-US" sz="1850" dirty="0"/>
-          </a:p>
-        </p:txBody>
-      </p:sp>
-      <p:sp>
-        <p:nvSpPr>
-          <p:cNvPr id="12" name="Text 4"/>
-          <p:cNvSpPr/>
-          <p:nvPr/>
-        </p:nvSpPr>
-        <p:spPr>
-          <a:xfrm>
-            <a:off x="6332776" y="2938760"/>
-            <a:ext cx="5203794" cy="1710333"/>
-          </a:xfrm>
-          <a:prstGeom prst="rect">
-            <a:avLst/>
-          </a:prstGeom>
-          <a:noFill/>
-          <a:ln/>
-        </p:spPr>
-        <p:txBody>
-          <a:bodyPr wrap="square" lIns="0" tIns="0" rIns="0" bIns="0" rtlCol="0" anchor="t">
-            <a:normAutofit/>
+            <a:r>
+              <a:rPr lang="en-US" sz="3450" dirty="0">
+                <a:latin typeface="Bitter Medium" panose="020B0604020202020204" charset="0"/>
+              </a:rPr>
+              <a:t>From Analysis Output to Command-Centre View</a:t>
+            </a:r>
+            <a:endParaRPr lang="en-IN" sz="3450" dirty="0">
+              <a:latin typeface="Bitter Medium" panose="020B0604020202020204" charset="0"/>
+            </a:endParaRPr>
+          </a:p>
+        </p:txBody>
+      </p:sp>
+      <p:sp>
+        <p:nvSpPr>
+          <p:cNvPr id="5" name="Rectangle 4"/>
+          <p:cNvSpPr/>
+          <p:nvPr/>
+        </p:nvSpPr>
+        <p:spPr>
+          <a:xfrm>
+            <a:off x="678860" y="5705499"/>
+            <a:ext cx="9835896" cy="715581"/>
+          </a:xfrm>
+          <a:prstGeom prst="rect">
+            <a:avLst/>
+          </a:prstGeom>
+        </p:spPr>
+        <p:txBody>
+          <a:bodyPr wrap="square">
+            <a:spAutoFit/>
           </a:bodyPr>
           <a:lstStyle/>
           <a:p>
-            <a:pPr marL="294640" indent="-294640" algn="l">
-              <a:lnSpc>
-                <a:spcPct val="133000"/>
-              </a:lnSpc>
-              <a:buSzPct val="100000"/>
-              <a:buChar char="•"/>
-            </a:pPr>
-            <a:r>
-              <a:rPr lang="en-US" sz="1450" kern="0" spc="-30" dirty="0">
-                <a:solidFill>
-                  <a:srgbClr val="2B2E3C"/>
-                </a:solidFill>
-                <a:latin typeface="Open Sans" pitchFamily="34" charset="0"/>
-                <a:ea typeface="Open Sans" pitchFamily="34" charset="-122"/>
-                <a:cs typeface="Open Sans" pitchFamily="34" charset="-120"/>
-              </a:rPr>
-              <a:t>Several real incidents were missed — limited coverage</a:t>
-            </a:r>
-            <a:endParaRPr lang="en-US" sz="1450" dirty="0"/>
-          </a:p>
-          <a:p>
-            <a:pPr marL="294640" indent="-294640" algn="l">
-              <a:lnSpc>
-                <a:spcPct val="133000"/>
-              </a:lnSpc>
-              <a:buSzPct val="100000"/>
-              <a:buChar char="•"/>
-            </a:pPr>
-            <a:r>
-              <a:rPr lang="en-US" sz="1450" kern="0" spc="-30" dirty="0">
-                <a:solidFill>
-                  <a:srgbClr val="2B2E3C"/>
-                </a:solidFill>
-                <a:latin typeface="Open Sans" pitchFamily="34" charset="0"/>
-                <a:ea typeface="Open Sans" pitchFamily="34" charset="-122"/>
-                <a:cs typeface="Open Sans" pitchFamily="34" charset="-120"/>
-              </a:rPr>
-              <a:t>Visibility depends on affected people posting</a:t>
-            </a:r>
-            <a:endParaRPr lang="en-US" sz="1450" dirty="0"/>
-          </a:p>
-          <a:p>
-            <a:pPr marL="294640" indent="-294640" algn="l">
-              <a:lnSpc>
-                <a:spcPct val="133000"/>
-              </a:lnSpc>
-              <a:buSzPct val="100000"/>
-              <a:buChar char="•"/>
-            </a:pPr>
-            <a:r>
-              <a:rPr lang="en-US" sz="1450" kern="0" spc="-30" dirty="0">
-                <a:solidFill>
-                  <a:srgbClr val="2B2E3C"/>
-                </a:solidFill>
-                <a:latin typeface="Open Sans" pitchFamily="34" charset="0"/>
-                <a:ea typeface="Open Sans" pitchFamily="34" charset="-122"/>
-                <a:cs typeface="Open Sans" pitchFamily="34" charset="-120"/>
-              </a:rPr>
-              <a:t>Neutral or subtle language can hide operational problems</a:t>
-            </a:r>
-            <a:endParaRPr lang="en-US" sz="1450" dirty="0"/>
-          </a:p>
-          <a:p>
-            <a:pPr marL="294640" indent="-294640" algn="l">
-              <a:lnSpc>
-                <a:spcPct val="133000"/>
-              </a:lnSpc>
-              <a:buSzPct val="100000"/>
-              <a:buChar char="•"/>
-            </a:pPr>
-            <a:r>
-              <a:rPr lang="en-US" sz="1450" kern="0" spc="-30" dirty="0">
-                <a:solidFill>
-                  <a:srgbClr val="2B2E3C"/>
-                </a:solidFill>
-                <a:latin typeface="Open Sans" pitchFamily="34" charset="0"/>
-                <a:ea typeface="Open Sans" pitchFamily="34" charset="-122"/>
-                <a:cs typeface="Open Sans" pitchFamily="34" charset="-120"/>
-              </a:rPr>
-              <a:t>Missing geography (30.12%) reduces market-level sensitivity</a:t>
-            </a:r>
-            <a:endParaRPr lang="en-US" sz="1450" dirty="0"/>
-          </a:p>
-        </p:txBody>
-      </p:sp>
-      <p:sp>
-        <p:nvSpPr>
-          <p:cNvPr id="13" name="Text 5"/>
-          <p:cNvSpPr/>
-          <p:nvPr/>
-        </p:nvSpPr>
-        <p:spPr>
-          <a:xfrm>
-            <a:off x="661475" y="5164138"/>
-            <a:ext cx="11478330" cy="302419"/>
-          </a:xfrm>
-          <a:prstGeom prst="rect">
-            <a:avLst/>
-          </a:prstGeom>
-          <a:noFill/>
-          <a:ln/>
-        </p:spPr>
-        <p:txBody>
-          <a:bodyPr wrap="none" lIns="0" tIns="0" rIns="0" bIns="0" rtlCol="0" anchor="t"/>
-          <a:lstStyle/>
-          <a:p>
-            <a:pPr marL="0" indent="0" algn="l">
-              <a:lnSpc>
-                <a:spcPct val="133000"/>
-              </a:lnSpc>
-              <a:buNone/>
-            </a:pPr>
-            <a:r>
-              <a:rPr lang="en-US" sz="1450" b="1" kern="0" spc="-30" dirty="0">
-                <a:solidFill>
-                  <a:srgbClr val="2B2E3C"/>
-                </a:solidFill>
-                <a:latin typeface="Open Sans Bold" pitchFamily="34" charset="0"/>
-                <a:ea typeface="Open Sans Bold" pitchFamily="34" charset="-122"/>
-                <a:cs typeface="Open Sans Bold" pitchFamily="34" charset="-120"/>
-              </a:rPr>
-              <a:t>Conclusion:</a:t>
-            </a:r>
-            <a:r>
-              <a:rPr lang="en-US" sz="1450" kern="0" spc="-30" dirty="0">
-                <a:solidFill>
-                  <a:srgbClr val="2B2E3C"/>
-                </a:solidFill>
-                <a:latin typeface="Open Sans" pitchFamily="34" charset="0"/>
-                <a:ea typeface="Open Sans" pitchFamily="34" charset="-122"/>
-                <a:cs typeface="Open Sans" pitchFamily="34" charset="-120"/>
-              </a:rPr>
-              <a:t> Useful as an early-warning layer, not sufficient as a standalone incident detector.</a:t>
-            </a:r>
-            <a:endParaRPr lang="en-US" sz="1450" dirty="0"/>
+            <a:r>
+              <a:rPr lang="en-IN" sz="1350" dirty="0">
+                <a:latin typeface="Open Sans" panose="020B0604020202020204" charset="0"/>
+                <a:ea typeface="Open Sans" panose="020B0604020202020204" charset="0"/>
+                <a:cs typeface="Open Sans" panose="020B0604020202020204" charset="0"/>
+              </a:rPr>
+              <a:t>• Historical simulation using the frozen 15-minute VSS outputs</a:t>
+            </a:r>
+          </a:p>
+          <a:p>
+            <a:r>
+              <a:rPr lang="en-IN" sz="1350" dirty="0">
+                <a:latin typeface="Open Sans" panose="020B0604020202020204" charset="0"/>
+                <a:ea typeface="Open Sans" panose="020B0604020202020204" charset="0"/>
+                <a:cs typeface="Open Sans" panose="020B0604020202020204" charset="0"/>
+              </a:rPr>
+              <a:t>• Market cards show current VSS, signal status and supporting evidence</a:t>
+            </a:r>
+          </a:p>
+          <a:p>
+            <a:r>
+              <a:rPr lang="en-IN" sz="1350" dirty="0">
+                <a:latin typeface="Open Sans" panose="020B0604020202020204" charset="0"/>
+                <a:ea typeface="Open Sans" panose="020B0604020202020204" charset="0"/>
+                <a:cs typeface="Open Sans" panose="020B0604020202020204" charset="0"/>
+              </a:rPr>
+              <a:t>• The interface is designed for human review — not autonomous incident diagnosis</a:t>
+            </a:r>
+          </a:p>
+        </p:txBody>
+      </p:sp>
+      <p:sp>
+        <p:nvSpPr>
+          <p:cNvPr id="6" name="Rectangle 5"/>
+          <p:cNvSpPr/>
+          <p:nvPr/>
+        </p:nvSpPr>
+        <p:spPr>
+          <a:xfrm>
+            <a:off x="2962656" y="5428327"/>
+            <a:ext cx="9329002" cy="246221"/>
+          </a:xfrm>
+          <a:prstGeom prst="rect">
+            <a:avLst/>
+          </a:prstGeom>
+        </p:spPr>
+        <p:txBody>
+          <a:bodyPr wrap="square">
+            <a:spAutoFit/>
+          </a:bodyPr>
+          <a:lstStyle/>
+          <a:p>
+            <a:r>
+              <a:rPr lang="en-US" sz="1000" dirty="0" smtClean="0">
+                <a:latin typeface="Open Sans" panose="020B0604020202020204" charset="0"/>
+                <a:ea typeface="Open Sans" panose="020B0604020202020204" charset="0"/>
+                <a:cs typeface="Open Sans" panose="020B0604020202020204" charset="0"/>
+              </a:rPr>
+              <a:t>** Prototype </a:t>
+            </a:r>
+            <a:r>
+              <a:rPr lang="en-US" sz="1000" dirty="0">
+                <a:latin typeface="Open Sans" panose="020B0604020202020204" charset="0"/>
+                <a:ea typeface="Open Sans" panose="020B0604020202020204" charset="0"/>
+                <a:cs typeface="Open Sans" panose="020B0604020202020204" charset="0"/>
+              </a:rPr>
+              <a:t>only — uses frozen assessment outputs; not a live production dashboard.</a:t>
+            </a:r>
+            <a:endParaRPr lang="en-IN" sz="1000" dirty="0">
+              <a:latin typeface="Open Sans" panose="020B0604020202020204" charset="0"/>
+              <a:ea typeface="Open Sans" panose="020B0604020202020204" charset="0"/>
+              <a:cs typeface="Open Sans" panose="020B0604020202020204" charset="0"/>
+            </a:endParaRPr>
           </a:p>
         </p:txBody>
       </p:sp>
     </p:spTree>
     <p:extLst>
       <p:ext uri="{BB962C8B-B14F-4D97-AF65-F5344CB8AC3E}">
-        <p14:creationId xmlns:p14="http://schemas.microsoft.com/office/powerpoint/2010/main" val="3042063563"/>
+        <p14:creationId xmlns:p14="http://schemas.microsoft.com/office/powerpoint/2010/main" val="3433858874"/>
       </p:ext>
     </p:extLst>
   </p:cSld>
   <p:clrMapOvr>
     <a:masterClrMapping/>
   </p:clrMapOvr>
-  <p:timing>
-    <p:tnLst>
-      <p:par>
-        <p:cTn id="1" dur="indefinite" restart="never" nodeType="tmRoot"/>
-      </p:par>
-    </p:tnLst>
-  </p:timing>
 </p:sld>
 </file>
 

</xml_diff>